<commit_message>
Replace limitations slide with a causal strengths/weaknesses slide
Frames the study on a correlational -> state-contingent -> interventional
scale for the 'Causal approaches in human neuroscience' course, and lists
strengths and weaknesses of the causal claim, with matching script.

Co-Authored-By: Claude Opus 5.5 <noreply@anthropic.com>
Claude-Session: https://claude.ai/code/session_01PsjNeB1kKbQQBu14TLVLAj
</commit_message>
<xml_diff>
--- a/Baratin2026_presentation/Baratin2026_ClosedLoop_aIns_presentation.pptx
+++ b/Baratin2026_presentation/Baratin2026_ClosedLoop_aIns_presentation.pptx
@@ -1065,9 +1065,11 @@
           <a:p>
             <a:r>
               <a:rPr lang="en-US" dirty="0"/>
-              <a:t>Like any study, this one has limitations, and I've grouped them into two columns.
-On the left are the limitations the authors themselves point out. They compared only high and low states, with no normal "middle" condition, so we can't tell whether the effect comes from up-states, down-states or both. Each patient only has a few electrodes, so only a small part of the brain is recorded. The slower theta rhythm behaved like gamma, which is unusual and suggests the effect may involve several rhythms. The authors say the cause-and-effect interpretation should be made carefully. And the absence of an effect in the vmPFC was unexpected.
-On the right are some further caveats. The sample is small, just seven insula sessions, and the main effect is only moderately significant, at p = 0.04. The title says activity "steers" decisions, but the system only waits for natural brain states. It doesn't create them, since there's no stimulation. That's stronger evidence than sorting trials afterwards, but it isn't direct proof of cause and effect. The trial-by-trial result relies on peak activity, and average activity in the same windows didn't predict choices. The choices are imaginary, with no real consequences. And the participants are epilepsy patients, so we're assuming the result carries over to healthy brains.</a:t>
+              <a:t>Since this course is about causal approaches, let's ask how strong a causal claim this study can make.
+The strip at the top is a simple scale of causal evidence. At the bottom are correlational studies: record brain activity, then sort the trials afterwards and look for a relationship. At the top are interventions like brain stimulation or lesions, where the researcher directly changes the brain and watches what happens to behaviour. This study sits in the middle. It doesn't change the brain, but it controls when the offer arrives relative to the brain's natural state. That's a real step up from sorting afterwards, but it isn't an intervention.
+The strengths are on the left. First, the timing is controlled in advance. Trials are assigned to up or down states before the choice happens, so there's no picking of convenient trials after the fact. Second, the comparison is fair. It's the same people and the same task, the conditions alternate, and difficulty and response times were matched, so those can't explain the difference. Third, the recordings come from inside the brain, which gives a precise, local measure of activity. Fourth, there are good controls: trials with epileptic spikes were removed, and the activity flip was absent in the pauses between trials. Fifth, the effect is specific to the insula and not the vmPFC. It also agrees with stimulation and lesion studies, so different methods point to the same conclusion.
+The weaknesses are on the right, and the first one is the most important for this course. The brain states are observed, not created. So a hidden third factor, like a momentary change in attention, arousal or mood, could raise insula activity and change the choice at the same time. Without stimulation, we can't rule that out. Second, there's no normal middle condition, so we don't know whether up-states, down-states or both drive the effect. Third, the proposed chain, where the pre-offer state leads to post-offer suppression which leads to the choice, is itself based on correlations within trials. The pre-offer activity didn't predict the choice trial by trial, and the result relied on peak rather than average activity. Fourth, the sample is small, seven insula sessions, with a moderate p-value of 0.04. Finally, the participants are epilepsy patients making imaginary choices, and the vmPFC "no effect" result is hard to interpret, because absence of evidence isn't evidence of absence.
+In short, this is stronger than correlational evidence but weaker than an intervention. The natural next step would be to stimulate the insula at the moments the system detects, which would turn this into a true causal test.</a:t>
             </a:r>
             <a:endParaRPr lang="en-US" dirty="0"/>
           </a:p>
@@ -7217,7 +7219,7 @@
         <p:spPr>
           <a:xfrm>
             <a:off x="548640" y="384048"/>
-            <a:ext cx="1552651" cy="292608"/>
+            <a:ext cx="2092147" cy="292608"/>
           </a:xfrm>
           <a:prstGeom prst="roundRect">
             <a:avLst>
@@ -7244,7 +7246,7 @@
         <p:spPr>
           <a:xfrm>
             <a:off x="548640" y="384048"/>
-            <a:ext cx="1552651" cy="292608"/>
+            <a:ext cx="2092147" cy="292608"/>
           </a:xfrm>
           <a:prstGeom prst="rect">
             <a:avLst/>
@@ -7268,7 +7270,7 @@
                 <a:ea typeface="Calibri" pitchFamily="34" charset="-122"/>
                 <a:cs typeface="Calibri" pitchFamily="34" charset="-120"/>
               </a:rPr>
-              <a:t>LIMITATIONS</a:t>
+              <a:t>CAUSAL APPRAISAL</a:t>
             </a:r>
             <a:endParaRPr lang="en-US" sz="1100" dirty="0"/>
           </a:p>
@@ -7307,7 +7309,7 @@
                 <a:ea typeface="Cambria" pitchFamily="34" charset="-122"/>
                 <a:cs typeface="Cambria" pitchFamily="34" charset="-120"/>
               </a:rPr>
-              <a:t>Limitations</a:t>
+              <a:t>Strengths and weaknesses: how causal is this evidence?</a:t>
             </a:r>
             <a:endParaRPr lang="en-US" sz="3000" dirty="0"/>
           </a:p>
@@ -7321,12 +7323,12 @@
         </p:nvSpPr>
         <p:spPr>
           <a:xfrm>
-            <a:off x="548640" y="1691640"/>
-            <a:ext cx="5440680" cy="4206240"/>
+            <a:off x="548640" y="1600200"/>
+            <a:ext cx="3429000" cy="822960"/>
           </a:xfrm>
           <a:prstGeom prst="roundRect">
             <a:avLst>
-              <a:gd name="adj" fmla="val 2609"/>
+              <a:gd name="adj" fmla="val 13333"/>
             </a:avLst>
           </a:prstGeom>
           <a:solidFill>
@@ -7348,8 +7350,8 @@
         </p:nvSpPr>
         <p:spPr>
           <a:xfrm>
-            <a:off x="822960" y="1828800"/>
-            <a:ext cx="4937760" cy="411480"/>
+            <a:off x="777240" y="1664208"/>
+            <a:ext cx="2971800" cy="347472"/>
           </a:xfrm>
           <a:prstGeom prst="rect">
             <a:avLst/>
@@ -7365,15 +7367,550 @@
               <a:buNone/>
             </a:pPr>
             <a:r>
+              <a:rPr lang="en-US" sz="1550" b="1" dirty="0">
+                <a:solidFill>
+                  <a:srgbClr val="1D2230"/>
+                </a:solidFill>
+                <a:latin typeface="Calibri" pitchFamily="34" charset="0"/>
+                <a:ea typeface="Calibri" pitchFamily="34" charset="-122"/>
+                <a:cs typeface="Calibri" pitchFamily="34" charset="-120"/>
+              </a:rPr>
+              <a:t>Correlational</a:t>
+            </a:r>
+            <a:endParaRPr lang="en-US" sz="1550" dirty="0"/>
+          </a:p>
+        </p:txBody>
+      </p:sp>
+      <p:sp>
+        <p:nvSpPr>
+          <p:cNvPr id="8" name="Text 5"/>
+          <p:cNvSpPr txBox="1"/>
+          <p:nvPr/>
+        </p:nvSpPr>
+        <p:spPr>
+          <a:xfrm>
+            <a:off x="777240" y="2011680"/>
+            <a:ext cx="2971800" cy="329184"/>
+          </a:xfrm>
+          <a:prstGeom prst="rect">
+            <a:avLst/>
+          </a:prstGeom>
+          <a:noFill/>
+          <a:ln/>
+        </p:spPr>
+        <p:txBody>
+          <a:bodyPr wrap="square" lIns="0" tIns="0" rIns="0" bIns="0" rtlCol="0" anchor="ctr"/>
+          <a:lstStyle/>
+          <a:p>
+            <a:pPr indent="0" marL="0">
+              <a:buNone/>
+            </a:pPr>
+            <a:r>
+              <a:rPr lang="en-US" sz="1250" dirty="0">
+                <a:solidFill>
+                  <a:srgbClr val="5B6275"/>
+                </a:solidFill>
+                <a:latin typeface="Calibri" pitchFamily="34" charset="0"/>
+                <a:ea typeface="Calibri" pitchFamily="34" charset="-122"/>
+                <a:cs typeface="Calibri" pitchFamily="34" charset="-120"/>
+              </a:rPr>
+              <a:t>record, then sort trials afterwards</a:t>
+            </a:r>
+            <a:endParaRPr lang="en-US" sz="1250" dirty="0"/>
+          </a:p>
+        </p:txBody>
+      </p:sp>
+      <p:sp>
+        <p:nvSpPr>
+          <p:cNvPr id="9" name="Text 6"/>
+          <p:cNvSpPr txBox="1"/>
+          <p:nvPr/>
+        </p:nvSpPr>
+        <p:spPr>
+          <a:xfrm>
+            <a:off x="3977640" y="1737360"/>
+            <a:ext cx="393192" cy="548640"/>
+          </a:xfrm>
+          <a:prstGeom prst="rect">
+            <a:avLst/>
+          </a:prstGeom>
+          <a:noFill/>
+          <a:ln/>
+        </p:spPr>
+        <p:txBody>
+          <a:bodyPr wrap="square" lIns="0" tIns="0" rIns="0" bIns="0" rtlCol="0" anchor="ctr"/>
+          <a:lstStyle/>
+          <a:p>
+            <a:pPr algn="ctr" indent="0" marL="0">
+              <a:buNone/>
+            </a:pPr>
+            <a:r>
+              <a:rPr lang="en-US" sz="2800" b="1" dirty="0">
+                <a:solidFill>
+                  <a:srgbClr val="9AA3B8"/>
+                </a:solidFill>
+                <a:latin typeface="Calibri" pitchFamily="34" charset="0"/>
+                <a:ea typeface="Calibri" pitchFamily="34" charset="-122"/>
+                <a:cs typeface="Calibri" pitchFamily="34" charset="-120"/>
+              </a:rPr>
+              <a:t>›</a:t>
+            </a:r>
+            <a:endParaRPr lang="en-US" sz="2800" dirty="0"/>
+          </a:p>
+        </p:txBody>
+      </p:sp>
+      <p:sp>
+        <p:nvSpPr>
+          <p:cNvPr id="10" name="Shape 7"/>
+          <p:cNvSpPr/>
+          <p:nvPr/>
+        </p:nvSpPr>
+        <p:spPr>
+          <a:xfrm>
+            <a:off x="4370832" y="1600200"/>
+            <a:ext cx="3429000" cy="822960"/>
+          </a:xfrm>
+          <a:prstGeom prst="roundRect">
+            <a:avLst>
+              <a:gd name="adj" fmla="val 13333"/>
+            </a:avLst>
+          </a:prstGeom>
+          <a:solidFill>
+            <a:srgbClr val="C8203F"/>
+          </a:solidFill>
+          <a:ln w="12700">
+            <a:solidFill>
+              <a:srgbClr val="C8203F"/>
+            </a:solidFill>
+            <a:prstDash val="solid"/>
+          </a:ln>
+        </p:spPr>
+      </p:sp>
+      <p:sp>
+        <p:nvSpPr>
+          <p:cNvPr id="11" name="Text 8"/>
+          <p:cNvSpPr txBox="1"/>
+          <p:nvPr/>
+        </p:nvSpPr>
+        <p:spPr>
+          <a:xfrm>
+            <a:off x="4599432" y="1664208"/>
+            <a:ext cx="2971800" cy="347472"/>
+          </a:xfrm>
+          <a:prstGeom prst="rect">
+            <a:avLst/>
+          </a:prstGeom>
+          <a:noFill/>
+          <a:ln/>
+        </p:spPr>
+        <p:txBody>
+          <a:bodyPr wrap="square" lIns="0" tIns="0" rIns="0" bIns="0" rtlCol="0" anchor="ctr"/>
+          <a:lstStyle/>
+          <a:p>
+            <a:pPr indent="0" marL="0">
+              <a:buNone/>
+            </a:pPr>
+            <a:r>
+              <a:rPr lang="en-US" sz="1550" b="1" dirty="0">
+                <a:solidFill>
+                  <a:srgbClr val="FFFFFF"/>
+                </a:solidFill>
+                <a:latin typeface="Calibri" pitchFamily="34" charset="0"/>
+                <a:ea typeface="Calibri" pitchFamily="34" charset="-122"/>
+                <a:cs typeface="Calibri" pitchFamily="34" charset="-120"/>
+              </a:rPr>
+              <a:t>State-contingent  ·  this study</a:t>
+            </a:r>
+            <a:endParaRPr lang="en-US" sz="1550" dirty="0"/>
+          </a:p>
+        </p:txBody>
+      </p:sp>
+      <p:sp>
+        <p:nvSpPr>
+          <p:cNvPr id="12" name="Text 9"/>
+          <p:cNvSpPr txBox="1"/>
+          <p:nvPr/>
+        </p:nvSpPr>
+        <p:spPr>
+          <a:xfrm>
+            <a:off x="4599432" y="2011680"/>
+            <a:ext cx="2971800" cy="329184"/>
+          </a:xfrm>
+          <a:prstGeom prst="rect">
+            <a:avLst/>
+          </a:prstGeom>
+          <a:noFill/>
+          <a:ln/>
+        </p:spPr>
+        <p:txBody>
+          <a:bodyPr wrap="square" lIns="0" tIns="0" rIns="0" bIns="0" rtlCol="0" anchor="ctr"/>
+          <a:lstStyle/>
+          <a:p>
+            <a:pPr indent="0" marL="0">
+              <a:buNone/>
+            </a:pPr>
+            <a:r>
+              <a:rPr lang="en-US" sz="1250" dirty="0">
+                <a:solidFill>
+                  <a:srgbClr val="FBE0E6"/>
+                </a:solidFill>
+                <a:latin typeface="Calibri" pitchFamily="34" charset="0"/>
+                <a:ea typeface="Calibri" pitchFamily="34" charset="-122"/>
+                <a:cs typeface="Calibri" pitchFamily="34" charset="-120"/>
+              </a:rPr>
+              <a:t>wait for a brain state, then present the offer</a:t>
+            </a:r>
+            <a:endParaRPr lang="en-US" sz="1250" dirty="0"/>
+          </a:p>
+        </p:txBody>
+      </p:sp>
+      <p:sp>
+        <p:nvSpPr>
+          <p:cNvPr id="13" name="Text 10"/>
+          <p:cNvSpPr txBox="1"/>
+          <p:nvPr/>
+        </p:nvSpPr>
+        <p:spPr>
+          <a:xfrm>
+            <a:off x="7799832" y="1737360"/>
+            <a:ext cx="393192" cy="548640"/>
+          </a:xfrm>
+          <a:prstGeom prst="rect">
+            <a:avLst/>
+          </a:prstGeom>
+          <a:noFill/>
+          <a:ln/>
+        </p:spPr>
+        <p:txBody>
+          <a:bodyPr wrap="square" lIns="0" tIns="0" rIns="0" bIns="0" rtlCol="0" anchor="ctr"/>
+          <a:lstStyle/>
+          <a:p>
+            <a:pPr algn="ctr" indent="0" marL="0">
+              <a:buNone/>
+            </a:pPr>
+            <a:r>
+              <a:rPr lang="en-US" sz="2800" b="1" dirty="0">
+                <a:solidFill>
+                  <a:srgbClr val="9AA3B8"/>
+                </a:solidFill>
+                <a:latin typeface="Calibri" pitchFamily="34" charset="0"/>
+                <a:ea typeface="Calibri" pitchFamily="34" charset="-122"/>
+                <a:cs typeface="Calibri" pitchFamily="34" charset="-120"/>
+              </a:rPr>
+              <a:t>›</a:t>
+            </a:r>
+            <a:endParaRPr lang="en-US" sz="2800" dirty="0"/>
+          </a:p>
+        </p:txBody>
+      </p:sp>
+      <p:sp>
+        <p:nvSpPr>
+          <p:cNvPr id="14" name="Shape 11"/>
+          <p:cNvSpPr/>
+          <p:nvPr/>
+        </p:nvSpPr>
+        <p:spPr>
+          <a:xfrm>
+            <a:off x="8193024" y="1600200"/>
+            <a:ext cx="3429000" cy="822960"/>
+          </a:xfrm>
+          <a:prstGeom prst="roundRect">
+            <a:avLst>
+              <a:gd name="adj" fmla="val 13333"/>
+            </a:avLst>
+          </a:prstGeom>
+          <a:solidFill>
+            <a:srgbClr val="F2F4F8"/>
+          </a:solidFill>
+          <a:ln w="12700">
+            <a:solidFill>
+              <a:srgbClr val="F2F4F8"/>
+            </a:solidFill>
+            <a:prstDash val="solid"/>
+          </a:ln>
+        </p:spPr>
+      </p:sp>
+      <p:sp>
+        <p:nvSpPr>
+          <p:cNvPr id="15" name="Text 12"/>
+          <p:cNvSpPr txBox="1"/>
+          <p:nvPr/>
+        </p:nvSpPr>
+        <p:spPr>
+          <a:xfrm>
+            <a:off x="8421624" y="1664208"/>
+            <a:ext cx="2971800" cy="347472"/>
+          </a:xfrm>
+          <a:prstGeom prst="rect">
+            <a:avLst/>
+          </a:prstGeom>
+          <a:noFill/>
+          <a:ln/>
+        </p:spPr>
+        <p:txBody>
+          <a:bodyPr wrap="square" lIns="0" tIns="0" rIns="0" bIns="0" rtlCol="0" anchor="ctr"/>
+          <a:lstStyle/>
+          <a:p>
+            <a:pPr indent="0" marL="0">
+              <a:buNone/>
+            </a:pPr>
+            <a:r>
+              <a:rPr lang="en-US" sz="1550" b="1" dirty="0">
+                <a:solidFill>
+                  <a:srgbClr val="1D2230"/>
+                </a:solidFill>
+                <a:latin typeface="Calibri" pitchFamily="34" charset="0"/>
+                <a:ea typeface="Calibri" pitchFamily="34" charset="-122"/>
+                <a:cs typeface="Calibri" pitchFamily="34" charset="-120"/>
+              </a:rPr>
+              <a:t>Interventional</a:t>
+            </a:r>
+            <a:endParaRPr lang="en-US" sz="1550" dirty="0"/>
+          </a:p>
+        </p:txBody>
+      </p:sp>
+      <p:sp>
+        <p:nvSpPr>
+          <p:cNvPr id="16" name="Text 13"/>
+          <p:cNvSpPr txBox="1"/>
+          <p:nvPr/>
+        </p:nvSpPr>
+        <p:spPr>
+          <a:xfrm>
+            <a:off x="8421624" y="2011680"/>
+            <a:ext cx="2971800" cy="329184"/>
+          </a:xfrm>
+          <a:prstGeom prst="rect">
+            <a:avLst/>
+          </a:prstGeom>
+          <a:noFill/>
+          <a:ln/>
+        </p:spPr>
+        <p:txBody>
+          <a:bodyPr wrap="square" lIns="0" tIns="0" rIns="0" bIns="0" rtlCol="0" anchor="ctr"/>
+          <a:lstStyle/>
+          <a:p>
+            <a:pPr indent="0" marL="0">
+              <a:buNone/>
+            </a:pPr>
+            <a:r>
+              <a:rPr lang="en-US" sz="1250" dirty="0">
+                <a:solidFill>
+                  <a:srgbClr val="5B6275"/>
+                </a:solidFill>
+                <a:latin typeface="Calibri" pitchFamily="34" charset="0"/>
+                <a:ea typeface="Calibri" pitchFamily="34" charset="-122"/>
+                <a:cs typeface="Calibri" pitchFamily="34" charset="-120"/>
+              </a:rPr>
+              <a:t>stimulate, lesion or induce the state</a:t>
+            </a:r>
+            <a:endParaRPr lang="en-US" sz="1250" dirty="0"/>
+          </a:p>
+        </p:txBody>
+      </p:sp>
+      <p:sp>
+        <p:nvSpPr>
+          <p:cNvPr id="17" name="Text 14"/>
+          <p:cNvSpPr txBox="1"/>
+          <p:nvPr/>
+        </p:nvSpPr>
+        <p:spPr>
+          <a:xfrm>
+            <a:off x="548640" y="2468880"/>
+            <a:ext cx="2743200" cy="256032"/>
+          </a:xfrm>
+          <a:prstGeom prst="rect">
+            <a:avLst/>
+          </a:prstGeom>
+          <a:noFill/>
+          <a:ln/>
+        </p:spPr>
+        <p:txBody>
+          <a:bodyPr wrap="square" lIns="0" tIns="0" rIns="0" bIns="0" rtlCol="0" anchor="ctr"/>
+          <a:lstStyle/>
+          <a:p>
+            <a:pPr indent="0" marL="0">
+              <a:buNone/>
+            </a:pPr>
+            <a:r>
+              <a:rPr lang="en-US" sz="1100" i="1" dirty="0">
+                <a:solidFill>
+                  <a:srgbClr val="5B6275"/>
+                </a:solidFill>
+                <a:latin typeface="Calibri" pitchFamily="34" charset="0"/>
+                <a:ea typeface="Calibri" pitchFamily="34" charset="-122"/>
+                <a:cs typeface="Calibri" pitchFamily="34" charset="-120"/>
+              </a:rPr>
+              <a:t>weaker causal evidence</a:t>
+            </a:r>
+            <a:endParaRPr lang="en-US" sz="1100" dirty="0"/>
+          </a:p>
+        </p:txBody>
+      </p:sp>
+      <p:sp>
+        <p:nvSpPr>
+          <p:cNvPr id="18" name="Text 15"/>
+          <p:cNvSpPr txBox="1"/>
+          <p:nvPr/>
+        </p:nvSpPr>
+        <p:spPr>
+          <a:xfrm>
+            <a:off x="8899855" y="2468880"/>
+            <a:ext cx="2743200" cy="256032"/>
+          </a:xfrm>
+          <a:prstGeom prst="rect">
+            <a:avLst/>
+          </a:prstGeom>
+          <a:noFill/>
+          <a:ln/>
+        </p:spPr>
+        <p:txBody>
+          <a:bodyPr wrap="square" lIns="0" tIns="0" rIns="0" bIns="0" rtlCol="0" anchor="ctr"/>
+          <a:lstStyle/>
+          <a:p>
+            <a:pPr algn="r" indent="0" marL="0">
+              <a:buNone/>
+            </a:pPr>
+            <a:r>
+              <a:rPr lang="en-US" sz="1100" i="1" dirty="0">
+                <a:solidFill>
+                  <a:srgbClr val="5B6275"/>
+                </a:solidFill>
+                <a:latin typeface="Calibri" pitchFamily="34" charset="0"/>
+                <a:ea typeface="Calibri" pitchFamily="34" charset="-122"/>
+                <a:cs typeface="Calibri" pitchFamily="34" charset="-120"/>
+              </a:rPr>
+              <a:t>stronger causal evidence</a:t>
+            </a:r>
+            <a:endParaRPr lang="en-US" sz="1100" dirty="0"/>
+          </a:p>
+        </p:txBody>
+      </p:sp>
+      <p:sp>
+        <p:nvSpPr>
+          <p:cNvPr id="19" name="Shape 16"/>
+          <p:cNvSpPr/>
+          <p:nvPr/>
+        </p:nvSpPr>
+        <p:spPr>
+          <a:xfrm>
+            <a:off x="548640" y="2816352"/>
+            <a:ext cx="5440680" cy="3493008"/>
+          </a:xfrm>
+          <a:prstGeom prst="roundRect">
+            <a:avLst>
+              <a:gd name="adj" fmla="val 3141"/>
+            </a:avLst>
+          </a:prstGeom>
+          <a:solidFill>
+            <a:srgbClr val="E7F4EC"/>
+          </a:solidFill>
+          <a:ln w="12700">
+            <a:solidFill>
+              <a:srgbClr val="E7F4EC"/>
+            </a:solidFill>
+            <a:prstDash val="solid"/>
+          </a:ln>
+        </p:spPr>
+      </p:sp>
+      <p:sp>
+        <p:nvSpPr>
+          <p:cNvPr id="20" name="Shape 17"/>
+          <p:cNvSpPr/>
+          <p:nvPr/>
+        </p:nvSpPr>
+        <p:spPr>
+          <a:xfrm>
+            <a:off x="822960" y="2999232"/>
+            <a:ext cx="384048" cy="384048"/>
+          </a:xfrm>
+          <a:prstGeom prst="ellipse">
+            <a:avLst/>
+          </a:prstGeom>
+          <a:solidFill>
+            <a:srgbClr val="1E8E5A"/>
+          </a:solidFill>
+          <a:ln w="12700">
+            <a:solidFill>
+              <a:srgbClr val="1E8E5A"/>
+            </a:solidFill>
+            <a:prstDash val="solid"/>
+          </a:ln>
+        </p:spPr>
+      </p:sp>
+      <p:sp>
+        <p:nvSpPr>
+          <p:cNvPr id="21" name="Text 18"/>
+          <p:cNvSpPr txBox="1"/>
+          <p:nvPr/>
+        </p:nvSpPr>
+        <p:spPr>
+          <a:xfrm>
+            <a:off x="822960" y="2999232"/>
+            <a:ext cx="384048" cy="384048"/>
+          </a:xfrm>
+          <a:prstGeom prst="rect">
+            <a:avLst/>
+          </a:prstGeom>
+          <a:noFill/>
+          <a:ln/>
+        </p:spPr>
+        <p:txBody>
+          <a:bodyPr wrap="square" lIns="0" tIns="0" rIns="0" bIns="0" rtlCol="0" anchor="ctr"/>
+          <a:lstStyle/>
+          <a:p>
+            <a:pPr algn="ctr" indent="0" marL="0">
+              <a:buNone/>
+            </a:pPr>
+            <a:r>
+              <a:rPr lang="en-US" sz="1800" b="1" dirty="0">
+                <a:solidFill>
+                  <a:srgbClr val="FFFFFF"/>
+                </a:solidFill>
+                <a:latin typeface="Calibri" pitchFamily="34" charset="0"/>
+                <a:ea typeface="Calibri" pitchFamily="34" charset="-122"/>
+                <a:cs typeface="Calibri" pitchFamily="34" charset="-120"/>
+              </a:rPr>
+              <a:t>+</a:t>
+            </a:r>
+            <a:endParaRPr lang="en-US" sz="1800" dirty="0"/>
+          </a:p>
+        </p:txBody>
+      </p:sp>
+      <p:sp>
+        <p:nvSpPr>
+          <p:cNvPr id="22" name="Text 19"/>
+          <p:cNvSpPr txBox="1"/>
+          <p:nvPr/>
+        </p:nvSpPr>
+        <p:spPr>
+          <a:xfrm>
+            <a:off x="1371600" y="2999232"/>
+            <a:ext cx="4114800" cy="384048"/>
+          </a:xfrm>
+          <a:prstGeom prst="rect">
+            <a:avLst/>
+          </a:prstGeom>
+          <a:noFill/>
+          <a:ln/>
+        </p:spPr>
+        <p:txBody>
+          <a:bodyPr wrap="square" lIns="0" tIns="0" rIns="0" bIns="0" rtlCol="0" anchor="ctr"/>
+          <a:lstStyle/>
+          <a:p>
+            <a:pPr indent="0" marL="0">
+              <a:buNone/>
+            </a:pPr>
+            <a:r>
               <a:rPr lang="en-US" sz="1900" b="1" dirty="0">
                 <a:solidFill>
-                  <a:srgbClr val="1D2230"/>
+                  <a:srgbClr val="1E8E5A"/>
                 </a:solidFill>
                 <a:latin typeface="Cambria" pitchFamily="34" charset="0"/>
                 <a:ea typeface="Cambria" pitchFamily="34" charset="-122"/>
                 <a:cs typeface="Cambria" pitchFamily="34" charset="-120"/>
               </a:rPr>
-              <a:t>Stated by the authors</a:t>
+              <a:t>Strengths</a:t>
             </a:r>
             <a:endParaRPr lang="en-US" sz="1900" dirty="0"/>
           </a:p>
@@ -7381,153 +7918,24 @@
       </p:sp>
       <p:sp>
         <p:nvSpPr>
-          <p:cNvPr id="8" name="Text 5"/>
-          <p:cNvSpPr txBox="1"/>
-          <p:nvPr/>
-        </p:nvSpPr>
-        <p:spPr>
-          <a:xfrm>
-            <a:off x="822960" y="2468880"/>
-            <a:ext cx="4937760" cy="3383280"/>
-          </a:xfrm>
-          <a:prstGeom prst="rect">
-            <a:avLst/>
-          </a:prstGeom>
-          <a:noFill/>
-          <a:ln/>
-        </p:spPr>
-        <p:txBody>
-          <a:bodyPr wrap="square" lIns="0" tIns="0" rIns="0" bIns="0" rtlCol="0" anchor="t"/>
-          <a:lstStyle/>
-          <a:p>
-            <a:pPr marL="203200" indent="-203200">
-              <a:spcAft>
-                <a:spcPts val="1200"/>
-              </a:spcAft>
-              <a:buSzPct val="100000"/>
-              <a:buChar char="•"/>
-            </a:pPr>
-            <a:r>
-              <a:rPr lang="en-US" sz="1700" dirty="0">
-                <a:solidFill>
-                  <a:srgbClr val="1D2230"/>
-                </a:solidFill>
-                <a:latin typeface="Calibri" pitchFamily="34" charset="0"/>
-                <a:ea typeface="Calibri" pitchFamily="34" charset="-122"/>
-                <a:cs typeface="Calibri" pitchFamily="34" charset="-120"/>
-              </a:rPr>
-              <a:t>No “normal” middle condition: is it the up-state, the down-state or both?</a:t>
-            </a:r>
-            <a:endParaRPr lang="en-US" sz="1700" dirty="0"/>
-          </a:p>
-          <a:p>
-            <a:pPr marL="203200" indent="-203200">
-              <a:spcAft>
-                <a:spcPts val="1200"/>
-              </a:spcAft>
-              <a:buSzPct val="100000"/>
-              <a:buChar char="•"/>
-            </a:pPr>
-            <a:r>
-              <a:rPr lang="en-US" sz="1700" dirty="0">
-                <a:solidFill>
-                  <a:srgbClr val="1D2230"/>
-                </a:solidFill>
-                <a:latin typeface="Calibri" pitchFamily="34" charset="0"/>
-                <a:ea typeface="Calibri" pitchFamily="34" charset="-122"/>
-                <a:cs typeface="Calibri" pitchFamily="34" charset="-120"/>
-              </a:rPr>
-              <a:t>Only a few electrodes per patient</a:t>
-            </a:r>
-            <a:endParaRPr lang="en-US" sz="1700" dirty="0"/>
-          </a:p>
-          <a:p>
-            <a:pPr marL="203200" indent="-203200">
-              <a:spcAft>
-                <a:spcPts val="1200"/>
-              </a:spcAft>
-              <a:buSzPct val="100000"/>
-              <a:buChar char="•"/>
-            </a:pPr>
-            <a:r>
-              <a:rPr lang="en-US" sz="1700" dirty="0">
-                <a:solidFill>
-                  <a:srgbClr val="1D2230"/>
-                </a:solidFill>
-                <a:latin typeface="Calibri" pitchFamily="34" charset="0"/>
-                <a:ea typeface="Calibri" pitchFamily="34" charset="-122"/>
-                <a:cs typeface="Calibri" pitchFamily="34" charset="-120"/>
-              </a:rPr>
-              <a:t>Slower theta waves behave like gamma: maybe a broader effect</a:t>
-            </a:r>
-            <a:endParaRPr lang="en-US" sz="1700" dirty="0"/>
-          </a:p>
-          <a:p>
-            <a:pPr marL="203200" indent="-203200">
-              <a:spcAft>
-                <a:spcPts val="1200"/>
-              </a:spcAft>
-              <a:buSzPct val="100000"/>
-              <a:buChar char="•"/>
-            </a:pPr>
-            <a:r>
-              <a:rPr lang="en-US" sz="1700" dirty="0">
-                <a:solidFill>
-                  <a:srgbClr val="1D2230"/>
-                </a:solidFill>
-                <a:latin typeface="Calibri" pitchFamily="34" charset="0"/>
-                <a:ea typeface="Calibri" pitchFamily="34" charset="-122"/>
-                <a:cs typeface="Calibri" pitchFamily="34" charset="-120"/>
-              </a:rPr>
-              <a:t>Cause and effect should be interpreted carefully</a:t>
-            </a:r>
-            <a:endParaRPr lang="en-US" sz="1700" dirty="0"/>
-          </a:p>
-          <a:p>
-            <a:pPr marL="203200" indent="-203200">
-              <a:spcAft>
-                <a:spcPts val="1200"/>
-              </a:spcAft>
-              <a:buSzPct val="100000"/>
-              <a:buChar char="•"/>
-            </a:pPr>
-            <a:r>
-              <a:rPr lang="en-US" sz="1700" dirty="0">
-                <a:solidFill>
-                  <a:srgbClr val="1D2230"/>
-                </a:solidFill>
-                <a:latin typeface="Calibri" pitchFamily="34" charset="0"/>
-                <a:ea typeface="Calibri" pitchFamily="34" charset="-122"/>
-                <a:cs typeface="Calibri" pitchFamily="34" charset="-120"/>
-              </a:rPr>
-              <a:t>vmPFC “no effect” was unexpected and very variable</a:t>
-            </a:r>
-            <a:endParaRPr lang="en-US" sz="1700" dirty="0"/>
-          </a:p>
-        </p:txBody>
-      </p:sp>
-      <p:sp>
-        <p:nvSpPr>
-          <p:cNvPr id="9" name="Shape 6"/>
+          <p:cNvPr id="23" name="Shape 20"/>
           <p:cNvSpPr/>
           <p:nvPr/>
         </p:nvSpPr>
         <p:spPr>
           <a:xfrm>
-            <a:off x="6217920" y="1691640"/>
-            <a:ext cx="5440680" cy="4206240"/>
-          </a:xfrm>
-          <a:prstGeom prst="roundRect">
-            <a:avLst>
-              <a:gd name="adj" fmla="val 2609"/>
-            </a:avLst>
+            <a:off x="822960" y="3630168"/>
+            <a:ext cx="91440" cy="91440"/>
+          </a:xfrm>
+          <a:prstGeom prst="ellipse">
+            <a:avLst/>
           </a:prstGeom>
           <a:solidFill>
-            <a:srgbClr val="161A26"/>
+            <a:srgbClr val="1E8E5A"/>
           </a:solidFill>
           <a:ln w="12700">
             <a:solidFill>
-              <a:srgbClr val="161A26"/>
+              <a:srgbClr val="1E8E5A"/>
             </a:solidFill>
             <a:prstDash val="solid"/>
           </a:ln>
@@ -7535,14 +7943,431 @@
       </p:sp>
       <p:sp>
         <p:nvSpPr>
-          <p:cNvPr id="10" name="Text 7"/>
-          <p:cNvSpPr txBox="1"/>
-          <p:nvPr/>
-        </p:nvSpPr>
-        <p:spPr>
-          <a:xfrm>
-            <a:off x="6492240" y="1828800"/>
-            <a:ext cx="4937760" cy="411480"/>
+          <p:cNvPr id="24" name="Text 21"/>
+          <p:cNvSpPr txBox="1"/>
+          <p:nvPr/>
+        </p:nvSpPr>
+        <p:spPr>
+          <a:xfrm>
+            <a:off x="1051560" y="3547872"/>
+            <a:ext cx="4709160" cy="502920"/>
+          </a:xfrm>
+          <a:prstGeom prst="rect">
+            <a:avLst/>
+          </a:prstGeom>
+          <a:noFill/>
+          <a:ln/>
+        </p:spPr>
+        <p:txBody>
+          <a:bodyPr wrap="square" lIns="0" tIns="0" rIns="0" bIns="0" rtlCol="0" anchor="t"/>
+          <a:lstStyle/>
+          <a:p>
+            <a:pPr indent="0" marL="0">
+              <a:buNone/>
+            </a:pPr>
+            <a:r>
+              <a:rPr lang="en-US" sz="1400" b="1" dirty="0">
+                <a:solidFill>
+                  <a:srgbClr val="1D2230"/>
+                </a:solidFill>
+                <a:latin typeface="Calibri" pitchFamily="34" charset="0"/>
+                <a:ea typeface="Calibri" pitchFamily="34" charset="-122"/>
+                <a:cs typeface="Calibri" pitchFamily="34" charset="-120"/>
+              </a:rPr>
+              <a:t>Timing fixed in advance: </a:t>
+            </a:r>
+            <a:pPr indent="0" marL="0">
+              <a:buNone/>
+            </a:pPr>
+            <a:r>
+              <a:rPr lang="en-US" sz="1400" dirty="0">
+                <a:solidFill>
+                  <a:srgbClr val="1D2230"/>
+                </a:solidFill>
+                <a:latin typeface="Calibri" pitchFamily="34" charset="0"/>
+                <a:ea typeface="Calibri" pitchFamily="34" charset="-122"/>
+                <a:cs typeface="Calibri" pitchFamily="34" charset="-120"/>
+              </a:rPr>
+              <a:t>no picking trials after the fact</a:t>
+            </a:r>
+            <a:endParaRPr lang="en-US" sz="1400" dirty="0"/>
+          </a:p>
+        </p:txBody>
+      </p:sp>
+      <p:sp>
+        <p:nvSpPr>
+          <p:cNvPr id="25" name="Shape 22"/>
+          <p:cNvSpPr/>
+          <p:nvPr/>
+        </p:nvSpPr>
+        <p:spPr>
+          <a:xfrm>
+            <a:off x="822960" y="4178808"/>
+            <a:ext cx="91440" cy="91440"/>
+          </a:xfrm>
+          <a:prstGeom prst="ellipse">
+            <a:avLst/>
+          </a:prstGeom>
+          <a:solidFill>
+            <a:srgbClr val="1E8E5A"/>
+          </a:solidFill>
+          <a:ln w="12700">
+            <a:solidFill>
+              <a:srgbClr val="1E8E5A"/>
+            </a:solidFill>
+            <a:prstDash val="solid"/>
+          </a:ln>
+        </p:spPr>
+      </p:sp>
+      <p:sp>
+        <p:nvSpPr>
+          <p:cNvPr id="26" name="Text 23"/>
+          <p:cNvSpPr txBox="1"/>
+          <p:nvPr/>
+        </p:nvSpPr>
+        <p:spPr>
+          <a:xfrm>
+            <a:off x="1051560" y="4096512"/>
+            <a:ext cx="4709160" cy="502920"/>
+          </a:xfrm>
+          <a:prstGeom prst="rect">
+            <a:avLst/>
+          </a:prstGeom>
+          <a:noFill/>
+          <a:ln/>
+        </p:spPr>
+        <p:txBody>
+          <a:bodyPr wrap="square" lIns="0" tIns="0" rIns="0" bIns="0" rtlCol="0" anchor="t"/>
+          <a:lstStyle/>
+          <a:p>
+            <a:pPr indent="0" marL="0">
+              <a:buNone/>
+            </a:pPr>
+            <a:r>
+              <a:rPr lang="en-US" sz="1400" b="1" dirty="0">
+                <a:solidFill>
+                  <a:srgbClr val="1D2230"/>
+                </a:solidFill>
+                <a:latin typeface="Calibri" pitchFamily="34" charset="0"/>
+                <a:ea typeface="Calibri" pitchFamily="34" charset="-122"/>
+                <a:cs typeface="Calibri" pitchFamily="34" charset="-120"/>
+              </a:rPr>
+              <a:t>Fair comparison: </a:t>
+            </a:r>
+            <a:pPr indent="0" marL="0">
+              <a:buNone/>
+            </a:pPr>
+            <a:r>
+              <a:rPr lang="en-US" sz="1400" dirty="0">
+                <a:solidFill>
+                  <a:srgbClr val="1D2230"/>
+                </a:solidFill>
+                <a:latin typeface="Calibri" pitchFamily="34" charset="0"/>
+                <a:ea typeface="Calibri" pitchFamily="34" charset="-122"/>
+                <a:cs typeface="Calibri" pitchFamily="34" charset="-120"/>
+              </a:rPr>
+              <a:t>same people and task, difficulty matched</a:t>
+            </a:r>
+            <a:endParaRPr lang="en-US" sz="1400" dirty="0"/>
+          </a:p>
+        </p:txBody>
+      </p:sp>
+      <p:sp>
+        <p:nvSpPr>
+          <p:cNvPr id="27" name="Shape 24"/>
+          <p:cNvSpPr/>
+          <p:nvPr/>
+        </p:nvSpPr>
+        <p:spPr>
+          <a:xfrm>
+            <a:off x="822960" y="4727448"/>
+            <a:ext cx="91440" cy="91440"/>
+          </a:xfrm>
+          <a:prstGeom prst="ellipse">
+            <a:avLst/>
+          </a:prstGeom>
+          <a:solidFill>
+            <a:srgbClr val="1E8E5A"/>
+          </a:solidFill>
+          <a:ln w="12700">
+            <a:solidFill>
+              <a:srgbClr val="1E8E5A"/>
+            </a:solidFill>
+            <a:prstDash val="solid"/>
+          </a:ln>
+        </p:spPr>
+      </p:sp>
+      <p:sp>
+        <p:nvSpPr>
+          <p:cNvPr id="28" name="Text 25"/>
+          <p:cNvSpPr txBox="1"/>
+          <p:nvPr/>
+        </p:nvSpPr>
+        <p:spPr>
+          <a:xfrm>
+            <a:off x="1051560" y="4645152"/>
+            <a:ext cx="4709160" cy="502920"/>
+          </a:xfrm>
+          <a:prstGeom prst="rect">
+            <a:avLst/>
+          </a:prstGeom>
+          <a:noFill/>
+          <a:ln/>
+        </p:spPr>
+        <p:txBody>
+          <a:bodyPr wrap="square" lIns="0" tIns="0" rIns="0" bIns="0" rtlCol="0" anchor="t"/>
+          <a:lstStyle/>
+          <a:p>
+            <a:pPr indent="0" marL="0">
+              <a:buNone/>
+            </a:pPr>
+            <a:r>
+              <a:rPr lang="en-US" sz="1400" b="1" dirty="0">
+                <a:solidFill>
+                  <a:srgbClr val="1D2230"/>
+                </a:solidFill>
+                <a:latin typeface="Calibri" pitchFamily="34" charset="0"/>
+                <a:ea typeface="Calibri" pitchFamily="34" charset="-122"/>
+                <a:cs typeface="Calibri" pitchFamily="34" charset="-120"/>
+              </a:rPr>
+              <a:t>Direct recordings </a:t>
+            </a:r>
+            <a:pPr indent="0" marL="0">
+              <a:buNone/>
+            </a:pPr>
+            <a:r>
+              <a:rPr lang="en-US" sz="1400" dirty="0">
+                <a:solidFill>
+                  <a:srgbClr val="1D2230"/>
+                </a:solidFill>
+                <a:latin typeface="Calibri" pitchFamily="34" charset="0"/>
+                <a:ea typeface="Calibri" pitchFamily="34" charset="-122"/>
+                <a:cs typeface="Calibri" pitchFamily="34" charset="-120"/>
+              </a:rPr>
+              <a:t>from inside the brain: precise and local</a:t>
+            </a:r>
+            <a:endParaRPr lang="en-US" sz="1400" dirty="0"/>
+          </a:p>
+        </p:txBody>
+      </p:sp>
+      <p:sp>
+        <p:nvSpPr>
+          <p:cNvPr id="29" name="Shape 26"/>
+          <p:cNvSpPr/>
+          <p:nvPr/>
+        </p:nvSpPr>
+        <p:spPr>
+          <a:xfrm>
+            <a:off x="822960" y="5276088"/>
+            <a:ext cx="91440" cy="91440"/>
+          </a:xfrm>
+          <a:prstGeom prst="ellipse">
+            <a:avLst/>
+          </a:prstGeom>
+          <a:solidFill>
+            <a:srgbClr val="1E8E5A"/>
+          </a:solidFill>
+          <a:ln w="12700">
+            <a:solidFill>
+              <a:srgbClr val="1E8E5A"/>
+            </a:solidFill>
+            <a:prstDash val="solid"/>
+          </a:ln>
+        </p:spPr>
+      </p:sp>
+      <p:sp>
+        <p:nvSpPr>
+          <p:cNvPr id="30" name="Text 27"/>
+          <p:cNvSpPr txBox="1"/>
+          <p:nvPr/>
+        </p:nvSpPr>
+        <p:spPr>
+          <a:xfrm>
+            <a:off x="1051560" y="5193792"/>
+            <a:ext cx="4709160" cy="502920"/>
+          </a:xfrm>
+          <a:prstGeom prst="rect">
+            <a:avLst/>
+          </a:prstGeom>
+          <a:noFill/>
+          <a:ln/>
+        </p:spPr>
+        <p:txBody>
+          <a:bodyPr wrap="square" lIns="0" tIns="0" rIns="0" bIns="0" rtlCol="0" anchor="t"/>
+          <a:lstStyle/>
+          <a:p>
+            <a:pPr indent="0" marL="0">
+              <a:buNone/>
+            </a:pPr>
+            <a:r>
+              <a:rPr lang="en-US" sz="1400" b="1" dirty="0">
+                <a:solidFill>
+                  <a:srgbClr val="1D2230"/>
+                </a:solidFill>
+                <a:latin typeface="Calibri" pitchFamily="34" charset="0"/>
+                <a:ea typeface="Calibri" pitchFamily="34" charset="-122"/>
+                <a:cs typeface="Calibri" pitchFamily="34" charset="-120"/>
+              </a:rPr>
+              <a:t>Good controls: </a:t>
+            </a:r>
+            <a:pPr indent="0" marL="0">
+              <a:buNone/>
+            </a:pPr>
+            <a:r>
+              <a:rPr lang="en-US" sz="1400" dirty="0">
+                <a:solidFill>
+                  <a:srgbClr val="1D2230"/>
+                </a:solidFill>
+                <a:latin typeface="Calibri" pitchFamily="34" charset="0"/>
+                <a:ea typeface="Calibri" pitchFamily="34" charset="-122"/>
+                <a:cs typeface="Calibri" pitchFamily="34" charset="-120"/>
+              </a:rPr>
+              <a:t>epileptic spikes removed; no flip between trials</a:t>
+            </a:r>
+            <a:endParaRPr lang="en-US" sz="1400" dirty="0"/>
+          </a:p>
+        </p:txBody>
+      </p:sp>
+      <p:sp>
+        <p:nvSpPr>
+          <p:cNvPr id="31" name="Shape 28"/>
+          <p:cNvSpPr/>
+          <p:nvPr/>
+        </p:nvSpPr>
+        <p:spPr>
+          <a:xfrm>
+            <a:off x="822960" y="5824728"/>
+            <a:ext cx="91440" cy="91440"/>
+          </a:xfrm>
+          <a:prstGeom prst="ellipse">
+            <a:avLst/>
+          </a:prstGeom>
+          <a:solidFill>
+            <a:srgbClr val="1E8E5A"/>
+          </a:solidFill>
+          <a:ln w="12700">
+            <a:solidFill>
+              <a:srgbClr val="1E8E5A"/>
+            </a:solidFill>
+            <a:prstDash val="solid"/>
+          </a:ln>
+        </p:spPr>
+      </p:sp>
+      <p:sp>
+        <p:nvSpPr>
+          <p:cNvPr id="32" name="Text 29"/>
+          <p:cNvSpPr txBox="1"/>
+          <p:nvPr/>
+        </p:nvSpPr>
+        <p:spPr>
+          <a:xfrm>
+            <a:off x="1051560" y="5742432"/>
+            <a:ext cx="4709160" cy="502920"/>
+          </a:xfrm>
+          <a:prstGeom prst="rect">
+            <a:avLst/>
+          </a:prstGeom>
+          <a:noFill/>
+          <a:ln/>
+        </p:spPr>
+        <p:txBody>
+          <a:bodyPr wrap="square" lIns="0" tIns="0" rIns="0" bIns="0" rtlCol="0" anchor="t"/>
+          <a:lstStyle/>
+          <a:p>
+            <a:pPr indent="0" marL="0">
+              <a:buNone/>
+            </a:pPr>
+            <a:r>
+              <a:rPr lang="en-US" sz="1400" b="1" dirty="0">
+                <a:solidFill>
+                  <a:srgbClr val="1D2230"/>
+                </a:solidFill>
+                <a:latin typeface="Calibri" pitchFamily="34" charset="0"/>
+                <a:ea typeface="Calibri" pitchFamily="34" charset="-122"/>
+                <a:cs typeface="Calibri" pitchFamily="34" charset="-120"/>
+              </a:rPr>
+              <a:t>Specific and consistent: </a:t>
+            </a:r>
+            <a:pPr indent="0" marL="0">
+              <a:buNone/>
+            </a:pPr>
+            <a:r>
+              <a:rPr lang="en-US" sz="1400" dirty="0">
+                <a:solidFill>
+                  <a:srgbClr val="1D2230"/>
+                </a:solidFill>
+                <a:latin typeface="Calibri" pitchFamily="34" charset="0"/>
+                <a:ea typeface="Calibri" pitchFamily="34" charset="-122"/>
+                <a:cs typeface="Calibri" pitchFamily="34" charset="-120"/>
+              </a:rPr>
+              <a:t>insula only; fits stimulation and lesion studies</a:t>
+            </a:r>
+            <a:endParaRPr lang="en-US" sz="1400" dirty="0"/>
+          </a:p>
+        </p:txBody>
+      </p:sp>
+      <p:sp>
+        <p:nvSpPr>
+          <p:cNvPr id="33" name="Shape 30"/>
+          <p:cNvSpPr/>
+          <p:nvPr/>
+        </p:nvSpPr>
+        <p:spPr>
+          <a:xfrm>
+            <a:off x="6217920" y="2816352"/>
+            <a:ext cx="5440680" cy="3493008"/>
+          </a:xfrm>
+          <a:prstGeom prst="roundRect">
+            <a:avLst>
+              <a:gd name="adj" fmla="val 3141"/>
+            </a:avLst>
+          </a:prstGeom>
+          <a:solidFill>
+            <a:srgbClr val="FBE8EC"/>
+          </a:solidFill>
+          <a:ln w="12700">
+            <a:solidFill>
+              <a:srgbClr val="FBE8EC"/>
+            </a:solidFill>
+            <a:prstDash val="solid"/>
+          </a:ln>
+        </p:spPr>
+      </p:sp>
+      <p:sp>
+        <p:nvSpPr>
+          <p:cNvPr id="34" name="Shape 31"/>
+          <p:cNvSpPr/>
+          <p:nvPr/>
+        </p:nvSpPr>
+        <p:spPr>
+          <a:xfrm>
+            <a:off x="6492240" y="2999232"/>
+            <a:ext cx="384048" cy="384048"/>
+          </a:xfrm>
+          <a:prstGeom prst="ellipse">
+            <a:avLst/>
+          </a:prstGeom>
+          <a:solidFill>
+            <a:srgbClr val="C8203F"/>
+          </a:solidFill>
+          <a:ln w="12700">
+            <a:solidFill>
+              <a:srgbClr val="C8203F"/>
+            </a:solidFill>
+            <a:prstDash val="solid"/>
+          </a:ln>
+        </p:spPr>
+      </p:sp>
+      <p:sp>
+        <p:nvSpPr>
+          <p:cNvPr id="35" name="Text 32"/>
+          <p:cNvSpPr txBox="1"/>
+          <p:nvPr/>
+        </p:nvSpPr>
+        <p:spPr>
+          <a:xfrm>
+            <a:off x="6492240" y="2999232"/>
+            <a:ext cx="384048" cy="384048"/>
           </a:xfrm>
           <a:prstGeom prst="rect">
             <a:avLst/>
@@ -7554,19 +8379,58 @@
           <a:bodyPr wrap="square" lIns="0" tIns="0" rIns="0" bIns="0" rtlCol="0" anchor="ctr"/>
           <a:lstStyle/>
           <a:p>
+            <a:pPr algn="ctr" indent="0" marL="0">
+              <a:buNone/>
+            </a:pPr>
+            <a:r>
+              <a:rPr lang="en-US" sz="1800" b="1" dirty="0">
+                <a:solidFill>
+                  <a:srgbClr val="FFFFFF"/>
+                </a:solidFill>
+                <a:latin typeface="Calibri" pitchFamily="34" charset="0"/>
+                <a:ea typeface="Calibri" pitchFamily="34" charset="-122"/>
+                <a:cs typeface="Calibri" pitchFamily="34" charset="-120"/>
+              </a:rPr>
+              <a:t>−</a:t>
+            </a:r>
+            <a:endParaRPr lang="en-US" sz="1800" dirty="0"/>
+          </a:p>
+        </p:txBody>
+      </p:sp>
+      <p:sp>
+        <p:nvSpPr>
+          <p:cNvPr id="36" name="Text 33"/>
+          <p:cNvSpPr txBox="1"/>
+          <p:nvPr/>
+        </p:nvSpPr>
+        <p:spPr>
+          <a:xfrm>
+            <a:off x="7040880" y="2999232"/>
+            <a:ext cx="4114800" cy="384048"/>
+          </a:xfrm>
+          <a:prstGeom prst="rect">
+            <a:avLst/>
+          </a:prstGeom>
+          <a:noFill/>
+          <a:ln/>
+        </p:spPr>
+        <p:txBody>
+          <a:bodyPr wrap="square" lIns="0" tIns="0" rIns="0" bIns="0" rtlCol="0" anchor="ctr"/>
+          <a:lstStyle/>
+          <a:p>
             <a:pPr indent="0" marL="0">
               <a:buNone/>
             </a:pPr>
             <a:r>
               <a:rPr lang="en-US" sz="1900" b="1" dirty="0">
                 <a:solidFill>
-                  <a:srgbClr val="FFFFFF"/>
+                  <a:srgbClr val="C8203F"/>
                 </a:solidFill>
                 <a:latin typeface="Cambria" pitchFamily="34" charset="0"/>
                 <a:ea typeface="Cambria" pitchFamily="34" charset="-122"/>
                 <a:cs typeface="Cambria" pitchFamily="34" charset="-120"/>
               </a:rPr>
-              <a:t>Further caveats</a:t>
+              <a:t>Weaknesses</a:t>
             </a:r>
             <a:endParaRPr lang="en-US" sz="1900" dirty="0"/>
           </a:p>
@@ -7574,14 +8438,39 @@
       </p:sp>
       <p:sp>
         <p:nvSpPr>
-          <p:cNvPr id="11" name="Text 8"/>
-          <p:cNvSpPr txBox="1"/>
-          <p:nvPr/>
-        </p:nvSpPr>
-        <p:spPr>
-          <a:xfrm>
-            <a:off x="6492240" y="2468880"/>
-            <a:ext cx="4937760" cy="3383280"/>
+          <p:cNvPr id="37" name="Shape 34"/>
+          <p:cNvSpPr/>
+          <p:nvPr/>
+        </p:nvSpPr>
+        <p:spPr>
+          <a:xfrm>
+            <a:off x="6492240" y="3630168"/>
+            <a:ext cx="91440" cy="91440"/>
+          </a:xfrm>
+          <a:prstGeom prst="ellipse">
+            <a:avLst/>
+          </a:prstGeom>
+          <a:solidFill>
+            <a:srgbClr val="C8203F"/>
+          </a:solidFill>
+          <a:ln w="12700">
+            <a:solidFill>
+              <a:srgbClr val="C8203F"/>
+            </a:solidFill>
+            <a:prstDash val="solid"/>
+          </a:ln>
+        </p:spPr>
+      </p:sp>
+      <p:sp>
+        <p:nvSpPr>
+          <p:cNvPr id="38" name="Text 35"/>
+          <p:cNvSpPr txBox="1"/>
+          <p:nvPr/>
+        </p:nvSpPr>
+        <p:spPr>
+          <a:xfrm>
+            <a:off x="6720840" y="3547872"/>
+            <a:ext cx="4709160" cy="502920"/>
           </a:xfrm>
           <a:prstGeom prst="rect">
             <a:avLst/>
@@ -7593,115 +8482,353 @@
           <a:bodyPr wrap="square" lIns="0" tIns="0" rIns="0" bIns="0" rtlCol="0" anchor="t"/>
           <a:lstStyle/>
           <a:p>
-            <a:pPr marL="203200" indent="-203200">
-              <a:spcAft>
-                <a:spcPts val="1200"/>
-              </a:spcAft>
-              <a:buSzPct val="100000"/>
-              <a:buChar char="•"/>
-            </a:pPr>
-            <a:r>
-              <a:rPr lang="en-US" sz="1700" dirty="0">
-                <a:solidFill>
-                  <a:srgbClr val="E6E9F0"/>
-                </a:solidFill>
-                <a:latin typeface="Calibri" pitchFamily="34" charset="0"/>
-                <a:ea typeface="Calibri" pitchFamily="34" charset="-122"/>
-                <a:cs typeface="Calibri" pitchFamily="34" charset="-120"/>
-              </a:rPr>
-              <a:t>Small sample: 7 insula sessions; main effect p = 0.04</a:t>
-            </a:r>
-            <a:endParaRPr lang="en-US" sz="1700" dirty="0"/>
-          </a:p>
-          <a:p>
-            <a:pPr marL="203200" indent="-203200">
-              <a:spcAft>
-                <a:spcPts val="1200"/>
-              </a:spcAft>
-              <a:buSzPct val="100000"/>
-              <a:buChar char="•"/>
-            </a:pPr>
-            <a:r>
-              <a:rPr lang="en-US" sz="1700" dirty="0">
-                <a:solidFill>
-                  <a:srgbClr val="E6E9F0"/>
-                </a:solidFill>
-                <a:latin typeface="Calibri" pitchFamily="34" charset="0"/>
-                <a:ea typeface="Calibri" pitchFamily="34" charset="-122"/>
-                <a:cs typeface="Calibri" pitchFamily="34" charset="-120"/>
-              </a:rPr>
-              <a:t>Brain states are waited for, not created: no stimulation</a:t>
-            </a:r>
-            <a:endParaRPr lang="en-US" sz="1700" dirty="0"/>
-          </a:p>
-          <a:p>
-            <a:pPr marL="203200" indent="-203200">
-              <a:spcAft>
-                <a:spcPts val="1200"/>
-              </a:spcAft>
-              <a:buSzPct val="100000"/>
-              <a:buChar char="•"/>
-            </a:pPr>
-            <a:r>
-              <a:rPr lang="en-US" sz="1700" dirty="0">
-                <a:solidFill>
-                  <a:srgbClr val="E6E9F0"/>
-                </a:solidFill>
-                <a:latin typeface="Calibri" pitchFamily="34" charset="0"/>
-                <a:ea typeface="Calibri" pitchFamily="34" charset="-122"/>
-                <a:cs typeface="Calibri" pitchFamily="34" charset="-120"/>
-              </a:rPr>
-              <a:t>Trial-by-trial link uses peak activity; average activity didn't predict choices</a:t>
-            </a:r>
-            <a:endParaRPr lang="en-US" sz="1700" dirty="0"/>
-          </a:p>
-          <a:p>
-            <a:pPr marL="203200" indent="-203200">
-              <a:spcAft>
-                <a:spcPts val="1200"/>
-              </a:spcAft>
-              <a:buSzPct val="100000"/>
-              <a:buChar char="•"/>
-            </a:pPr>
-            <a:r>
-              <a:rPr lang="en-US" sz="1700" dirty="0">
-                <a:solidFill>
-                  <a:srgbClr val="E6E9F0"/>
-                </a:solidFill>
-                <a:latin typeface="Calibri" pitchFamily="34" charset="0"/>
-                <a:ea typeface="Calibri" pitchFamily="34" charset="-122"/>
-                <a:cs typeface="Calibri" pitchFamily="34" charset="-120"/>
-              </a:rPr>
-              <a:t>Imaginary choices with no real consequences</a:t>
-            </a:r>
-            <a:endParaRPr lang="en-US" sz="1700" dirty="0"/>
-          </a:p>
-          <a:p>
-            <a:pPr marL="203200" indent="-203200">
-              <a:spcAft>
-                <a:spcPts val="1200"/>
-              </a:spcAft>
-              <a:buSzPct val="100000"/>
-              <a:buChar char="•"/>
-            </a:pPr>
-            <a:r>
-              <a:rPr lang="en-US" sz="1700" dirty="0">
-                <a:solidFill>
-                  <a:srgbClr val="E6E9F0"/>
-                </a:solidFill>
-                <a:latin typeface="Calibri" pitchFamily="34" charset="0"/>
-                <a:ea typeface="Calibri" pitchFamily="34" charset="-122"/>
-                <a:cs typeface="Calibri" pitchFamily="34" charset="-120"/>
-              </a:rPr>
-              <a:t>Epilepsy patients: healthy brains may differ</a:t>
-            </a:r>
-            <a:endParaRPr lang="en-US" sz="1700" dirty="0"/>
-          </a:p>
-        </p:txBody>
-      </p:sp>
-      <p:sp>
-        <p:nvSpPr>
-          <p:cNvPr id="12" name="Text 9"/>
+            <a:pPr indent="0" marL="0">
+              <a:buNone/>
+            </a:pPr>
+            <a:r>
+              <a:rPr lang="en-US" sz="1400" b="1" dirty="0">
+                <a:solidFill>
+                  <a:srgbClr val="1D2230"/>
+                </a:solidFill>
+                <a:latin typeface="Calibri" pitchFamily="34" charset="0"/>
+                <a:ea typeface="Calibri" pitchFamily="34" charset="-122"/>
+                <a:cs typeface="Calibri" pitchFamily="34" charset="-120"/>
+              </a:rPr>
+              <a:t>Observed, not created: </a:t>
+            </a:r>
+            <a:pPr indent="0" marL="0">
+              <a:buNone/>
+            </a:pPr>
+            <a:r>
+              <a:rPr lang="en-US" sz="1400" dirty="0">
+                <a:solidFill>
+                  <a:srgbClr val="1D2230"/>
+                </a:solidFill>
+                <a:latin typeface="Calibri" pitchFamily="34" charset="0"/>
+                <a:ea typeface="Calibri" pitchFamily="34" charset="-122"/>
+                <a:cs typeface="Calibri" pitchFamily="34" charset="-120"/>
+              </a:rPr>
+              <a:t>a hidden factor (e.g. arousal) could drive both</a:t>
+            </a:r>
+            <a:endParaRPr lang="en-US" sz="1400" dirty="0"/>
+          </a:p>
+        </p:txBody>
+      </p:sp>
+      <p:sp>
+        <p:nvSpPr>
+          <p:cNvPr id="39" name="Shape 36"/>
+          <p:cNvSpPr/>
+          <p:nvPr/>
+        </p:nvSpPr>
+        <p:spPr>
+          <a:xfrm>
+            <a:off x="6492240" y="4178808"/>
+            <a:ext cx="91440" cy="91440"/>
+          </a:xfrm>
+          <a:prstGeom prst="ellipse">
+            <a:avLst/>
+          </a:prstGeom>
+          <a:solidFill>
+            <a:srgbClr val="C8203F"/>
+          </a:solidFill>
+          <a:ln w="12700">
+            <a:solidFill>
+              <a:srgbClr val="C8203F"/>
+            </a:solidFill>
+            <a:prstDash val="solid"/>
+          </a:ln>
+        </p:spPr>
+      </p:sp>
+      <p:sp>
+        <p:nvSpPr>
+          <p:cNvPr id="40" name="Text 37"/>
+          <p:cNvSpPr txBox="1"/>
+          <p:nvPr/>
+        </p:nvSpPr>
+        <p:spPr>
+          <a:xfrm>
+            <a:off x="6720840" y="4096512"/>
+            <a:ext cx="4709160" cy="502920"/>
+          </a:xfrm>
+          <a:prstGeom prst="rect">
+            <a:avLst/>
+          </a:prstGeom>
+          <a:noFill/>
+          <a:ln/>
+        </p:spPr>
+        <p:txBody>
+          <a:bodyPr wrap="square" lIns="0" tIns="0" rIns="0" bIns="0" rtlCol="0" anchor="t"/>
+          <a:lstStyle/>
+          <a:p>
+            <a:pPr indent="0" marL="0">
+              <a:buNone/>
+            </a:pPr>
+            <a:r>
+              <a:rPr lang="en-US" sz="1400" b="1" dirty="0">
+                <a:solidFill>
+                  <a:srgbClr val="1D2230"/>
+                </a:solidFill>
+                <a:latin typeface="Calibri" pitchFamily="34" charset="0"/>
+                <a:ea typeface="Calibri" pitchFamily="34" charset="-122"/>
+                <a:cs typeface="Calibri" pitchFamily="34" charset="-120"/>
+              </a:rPr>
+              <a:t>No middle condition: </a:t>
+            </a:r>
+            <a:pPr indent="0" marL="0">
+              <a:buNone/>
+            </a:pPr>
+            <a:r>
+              <a:rPr lang="en-US" sz="1400" dirty="0">
+                <a:solidFill>
+                  <a:srgbClr val="1D2230"/>
+                </a:solidFill>
+                <a:latin typeface="Calibri" pitchFamily="34" charset="0"/>
+                <a:ea typeface="Calibri" pitchFamily="34" charset="-122"/>
+                <a:cs typeface="Calibri" pitchFamily="34" charset="-120"/>
+              </a:rPr>
+              <a:t>up-state, down-state or both?</a:t>
+            </a:r>
+            <a:endParaRPr lang="en-US" sz="1400" dirty="0"/>
+          </a:p>
+        </p:txBody>
+      </p:sp>
+      <p:sp>
+        <p:nvSpPr>
+          <p:cNvPr id="41" name="Shape 38"/>
+          <p:cNvSpPr/>
+          <p:nvPr/>
+        </p:nvSpPr>
+        <p:spPr>
+          <a:xfrm>
+            <a:off x="6492240" y="4727448"/>
+            <a:ext cx="91440" cy="91440"/>
+          </a:xfrm>
+          <a:prstGeom prst="ellipse">
+            <a:avLst/>
+          </a:prstGeom>
+          <a:solidFill>
+            <a:srgbClr val="C8203F"/>
+          </a:solidFill>
+          <a:ln w="12700">
+            <a:solidFill>
+              <a:srgbClr val="C8203F"/>
+            </a:solidFill>
+            <a:prstDash val="solid"/>
+          </a:ln>
+        </p:spPr>
+      </p:sp>
+      <p:sp>
+        <p:nvSpPr>
+          <p:cNvPr id="42" name="Text 39"/>
+          <p:cNvSpPr txBox="1"/>
+          <p:nvPr/>
+        </p:nvSpPr>
+        <p:spPr>
+          <a:xfrm>
+            <a:off x="6720840" y="4645152"/>
+            <a:ext cx="4709160" cy="502920"/>
+          </a:xfrm>
+          <a:prstGeom prst="rect">
+            <a:avLst/>
+          </a:prstGeom>
+          <a:noFill/>
+          <a:ln/>
+        </p:spPr>
+        <p:txBody>
+          <a:bodyPr wrap="square" lIns="0" tIns="0" rIns="0" bIns="0" rtlCol="0" anchor="t"/>
+          <a:lstStyle/>
+          <a:p>
+            <a:pPr indent="0" marL="0">
+              <a:buNone/>
+            </a:pPr>
+            <a:r>
+              <a:rPr lang="en-US" sz="1400" b="1" dirty="0">
+                <a:solidFill>
+                  <a:srgbClr val="1D2230"/>
+                </a:solidFill>
+                <a:latin typeface="Calibri" pitchFamily="34" charset="0"/>
+                <a:ea typeface="Calibri" pitchFamily="34" charset="-122"/>
+                <a:cs typeface="Calibri" pitchFamily="34" charset="-120"/>
+              </a:rPr>
+              <a:t>Mechanism is correlational: </a:t>
+            </a:r>
+            <a:pPr indent="0" marL="0">
+              <a:buNone/>
+            </a:pPr>
+            <a:r>
+              <a:rPr lang="en-US" sz="1400" dirty="0">
+                <a:solidFill>
+                  <a:srgbClr val="1D2230"/>
+                </a:solidFill>
+                <a:latin typeface="Calibri" pitchFamily="34" charset="0"/>
+                <a:ea typeface="Calibri" pitchFamily="34" charset="-122"/>
+                <a:cs typeface="Calibri" pitchFamily="34" charset="-120"/>
+              </a:rPr>
+              <a:t>relies on peak (not average) activity</a:t>
+            </a:r>
+            <a:endParaRPr lang="en-US" sz="1400" dirty="0"/>
+          </a:p>
+        </p:txBody>
+      </p:sp>
+      <p:sp>
+        <p:nvSpPr>
+          <p:cNvPr id="43" name="Shape 40"/>
+          <p:cNvSpPr/>
+          <p:nvPr/>
+        </p:nvSpPr>
+        <p:spPr>
+          <a:xfrm>
+            <a:off x="6492240" y="5276088"/>
+            <a:ext cx="91440" cy="91440"/>
+          </a:xfrm>
+          <a:prstGeom prst="ellipse">
+            <a:avLst/>
+          </a:prstGeom>
+          <a:solidFill>
+            <a:srgbClr val="C8203F"/>
+          </a:solidFill>
+          <a:ln w="12700">
+            <a:solidFill>
+              <a:srgbClr val="C8203F"/>
+            </a:solidFill>
+            <a:prstDash val="solid"/>
+          </a:ln>
+        </p:spPr>
+      </p:sp>
+      <p:sp>
+        <p:nvSpPr>
+          <p:cNvPr id="44" name="Text 41"/>
+          <p:cNvSpPr txBox="1"/>
+          <p:nvPr/>
+        </p:nvSpPr>
+        <p:spPr>
+          <a:xfrm>
+            <a:off x="6720840" y="5193792"/>
+            <a:ext cx="4709160" cy="502920"/>
+          </a:xfrm>
+          <a:prstGeom prst="rect">
+            <a:avLst/>
+          </a:prstGeom>
+          <a:noFill/>
+          <a:ln/>
+        </p:spPr>
+        <p:txBody>
+          <a:bodyPr wrap="square" lIns="0" tIns="0" rIns="0" bIns="0" rtlCol="0" anchor="t"/>
+          <a:lstStyle/>
+          <a:p>
+            <a:pPr indent="0" marL="0">
+              <a:buNone/>
+            </a:pPr>
+            <a:r>
+              <a:rPr lang="en-US" sz="1400" b="1" dirty="0">
+                <a:solidFill>
+                  <a:srgbClr val="1D2230"/>
+                </a:solidFill>
+                <a:latin typeface="Calibri" pitchFamily="34" charset="0"/>
+                <a:ea typeface="Calibri" pitchFamily="34" charset="-122"/>
+                <a:cs typeface="Calibri" pitchFamily="34" charset="-120"/>
+              </a:rPr>
+              <a:t>Small sample: </a:t>
+            </a:r>
+            <a:pPr indent="0" marL="0">
+              <a:buNone/>
+            </a:pPr>
+            <a:r>
+              <a:rPr lang="en-US" sz="1400" dirty="0">
+                <a:solidFill>
+                  <a:srgbClr val="1D2230"/>
+                </a:solidFill>
+                <a:latin typeface="Calibri" pitchFamily="34" charset="0"/>
+                <a:ea typeface="Calibri" pitchFamily="34" charset="-122"/>
+                <a:cs typeface="Calibri" pitchFamily="34" charset="-120"/>
+              </a:rPr>
+              <a:t>7 insula sessions, p = 0.04</a:t>
+            </a:r>
+            <a:endParaRPr lang="en-US" sz="1400" dirty="0"/>
+          </a:p>
+        </p:txBody>
+      </p:sp>
+      <p:sp>
+        <p:nvSpPr>
+          <p:cNvPr id="45" name="Shape 42"/>
+          <p:cNvSpPr/>
+          <p:nvPr/>
+        </p:nvSpPr>
+        <p:spPr>
+          <a:xfrm>
+            <a:off x="6492240" y="5824728"/>
+            <a:ext cx="91440" cy="91440"/>
+          </a:xfrm>
+          <a:prstGeom prst="ellipse">
+            <a:avLst/>
+          </a:prstGeom>
+          <a:solidFill>
+            <a:srgbClr val="C8203F"/>
+          </a:solidFill>
+          <a:ln w="12700">
+            <a:solidFill>
+              <a:srgbClr val="C8203F"/>
+            </a:solidFill>
+            <a:prstDash val="solid"/>
+          </a:ln>
+        </p:spPr>
+      </p:sp>
+      <p:sp>
+        <p:nvSpPr>
+          <p:cNvPr id="46" name="Text 43"/>
+          <p:cNvSpPr txBox="1"/>
+          <p:nvPr/>
+        </p:nvSpPr>
+        <p:spPr>
+          <a:xfrm>
+            <a:off x="6720840" y="5742432"/>
+            <a:ext cx="4709160" cy="502920"/>
+          </a:xfrm>
+          <a:prstGeom prst="rect">
+            <a:avLst/>
+          </a:prstGeom>
+          <a:noFill/>
+          <a:ln/>
+        </p:spPr>
+        <p:txBody>
+          <a:bodyPr wrap="square" lIns="0" tIns="0" rIns="0" bIns="0" rtlCol="0" anchor="t"/>
+          <a:lstStyle/>
+          <a:p>
+            <a:pPr indent="0" marL="0">
+              <a:buNone/>
+            </a:pPr>
+            <a:r>
+              <a:rPr lang="en-US" sz="1400" b="1" dirty="0">
+                <a:solidFill>
+                  <a:srgbClr val="1D2230"/>
+                </a:solidFill>
+                <a:latin typeface="Calibri" pitchFamily="34" charset="0"/>
+                <a:ea typeface="Calibri" pitchFamily="34" charset="-122"/>
+                <a:cs typeface="Calibri" pitchFamily="34" charset="-120"/>
+              </a:rPr>
+              <a:t>Generalisation: </a:t>
+            </a:r>
+            <a:pPr indent="0" marL="0">
+              <a:buNone/>
+            </a:pPr>
+            <a:r>
+              <a:rPr lang="en-US" sz="1400" dirty="0">
+                <a:solidFill>
+                  <a:srgbClr val="1D2230"/>
+                </a:solidFill>
+                <a:latin typeface="Calibri" pitchFamily="34" charset="0"/>
+                <a:ea typeface="Calibri" pitchFamily="34" charset="-122"/>
+                <a:cs typeface="Calibri" pitchFamily="34" charset="-120"/>
+              </a:rPr>
+              <a:t>epilepsy patients and imaginary choices</a:t>
+            </a:r>
+            <a:endParaRPr lang="en-US" sz="1400" dirty="0"/>
+          </a:p>
+        </p:txBody>
+      </p:sp>
+      <p:sp>
+        <p:nvSpPr>
+          <p:cNvPr id="47" name="Text 44"/>
           <p:cNvSpPr txBox="1"/>
           <p:nvPr/>
         </p:nvSpPr>
@@ -7740,7 +8867,7 @@
       </p:sp>
       <p:sp>
         <p:nvSpPr>
-          <p:cNvPr id="13" name="Text 10"/>
+          <p:cNvPr id="48" name="Text 45"/>
           <p:cNvSpPr txBox="1"/>
           <p:nvPr/>
         </p:nvSpPr>

</xml_diff>